<commit_message>
Rebuild the deck and dissertation after the asterisk fix
The deck could not be written last time because PowerPoint had the file open.
403 tests, perturbation proof passes, kappa still 0.643, no live API calls.
</commit_message>
<xml_diff>
--- a/submission/CMP7200_Viva_Presentation.pptx
+++ b/submission/CMP7200_Viva_Presentation.pptx
@@ -5881,7 +5881,7 @@
                 </a:solidFill>
                 <a:latin typeface="Calibri"/>
               </a:rPr>
-              <a:t>15,928</a:t>
+              <a:t>16,169</a:t>
             </a:r>
           </a:p>
         </p:txBody>
@@ -5959,7 +5959,7 @@
                 </a:solidFill>
                 <a:latin typeface="Calibri"/>
               </a:rPr>
-              <a:t>393</a:t>
+              <a:t>403</a:t>
             </a:r>
           </a:p>
         </p:txBody>
@@ -9226,7 +9226,7 @@
                 </a:solidFill>
                 <a:latin typeface="Calibri"/>
               </a:rPr>
-              <a:t>393</a:t>
+              <a:t>403</a:t>
             </a:r>
           </a:p>
         </p:txBody>

</xml_diff>

<commit_message>
Say how the agents run on each approach slide
The one thing missing from the per-approach slides: B queues its four search
and coordination agents in a single sequential crew, C runs the three
specialists at once in a thread pool, and D is AI then plain Python then AI.
Each approach slide now states its run order in one teal line, and the
comparison table gains a "how the agents run" row.

This also fixes the reading of the time row. B is slow partly because it
queues; D is the fastest even though its Python fetches also run one after
another, so the saving comes from having 2 AI calls, not from parallelism.
That is now in the speaker notes rather than left to be inferred.

Stat captions get a 0.5in box so the lower rows stop hanging off the slide.
</commit_message>
<xml_diff>
--- a/submission/CMP7200_Viva_Presentation.pptx
+++ b/submission/CMP7200_Viva_Presentation.pptx
@@ -720,7 +720,7 @@
           <a:lstStyle/>
           <a:p>
             <a:r>
-              <a:t>This was my original proposal. The hotel agent has eight tools and is allowed ten thinking steps, and every step is a separate AI call that re-sends the conversation and all eight tool descriptions. It took 20.6 AI calls and 372 seconds, gave broken output twice, and never once called the attractions or the restaurant tool - while still producing a plan that looked complete.</a:t>
+              <a:t>This was my original proposal. The four search and coordination agents run in one sequential crew, so the hotel agent cannot start until the flight agent has finished. The hotel agent has eight tools and is allowed ten thinking steps, and every step is a separate AI call that re-sends the conversation and all eight tool descriptions. It took 20.6 AI calls and 372 seconds, gave broken output twice, and never once called the attractions or the restaurant tool - while still producing a plan that looked complete.</a:t>
             </a:r>
           </a:p>
         </p:txBody>
@@ -790,7 +790,7 @@
           <a:lstStyle/>
           <a:p>
             <a:r>
-              <a:t>Approach C is Approach B done properly, and it exists so nobody can say D only won because B was set up badly. Instead of handing the AI twelve thousand characters of hotel data, it gets three lines - Theodora Pension $33 10/10, and so on. Settings alone removed 89% of the tokens. Being honest about that is what makes the next slide believable.</a:t>
+              <a:t>Approach C is Approach B done properly, and it exists so nobody can say D only won because B was set up badly. Two things changed. Running the three specialists in parallel instead of in a queue is most of why the time drops from 372 seconds to 37. And instead of handing the AI twelve thousand characters of hotel data it gets three lines - Theodora Pension $33 10/10, and so on - which is most of why the tokens drop by 89%. Being honest about that is what makes the next slide believable.</a:t>
             </a:r>
           </a:p>
         </p:txBody>
@@ -860,7 +860,7 @@
           <a:lstStyle/>
           <a:p>
             <a:r>
-              <a:t>This is the one that ships. AI understands the request, Python fetches the data, AI writes the plan. No agent holds a search tool in the measured run, so it makes exactly 5 searches every time in the same order - an IF statement decides rather than a model, so nothing can be skipped, which is exactly what B and C both did. If asked about the four helper tools in the web app: they are on the coordinator for the interactive path, and the measured arm strips them so the comparison is clean.</a:t>
+              <a:t>This is the one that ships. Once we know the place and the dates, there is nothing left for AI to decide - so AI understands the request, Python fetches the data, AI writes the plan. No agent holds a search tool in the measured run, so it makes exactly 5 searches every time in the same order - an IF statement decides rather than a model, so nothing can be skipped, which is exactly what B and C both did. Worth noting the Python fetches also run one after another, so D is not faster because of parallelism: it is faster because there are only 2 AI calls in it. If asked about the four helper tools in the web app: they are on the coordinator for the interactive path, and the measured arm strips them so the comparison is clean.</a:t>
             </a:r>
           </a:p>
         </p:txBody>
@@ -930,7 +930,7 @@
           <a:lstStyle/>
           <a:p>
             <a:r>
-              <a:t>Read the last row carefully. C is 56% and D is 47%, and their ranges overlap, so I cannot claim D is better grounded and I do not. What does not overlap is the token count. The claim is cheaper and faster with no measurable penalty - a smaller claim than the numbers first suggest, and the only one the data supports.</a:t>
+              <a:t>Two rows to point at. The run row explains the time row: B queues its agents so it takes 372 seconds, C runs three of them at once and drops to 37. D fetches its data one call after another in Python and is still the fastest at 23, because the saving comes from removing AI steps, not from running things in parallel. Then read the last row carefully: C is 56% and D is 47%, and their ranges overlap, so I cannot claim D is better grounded and I do not. What does not overlap is the token count. The claim is cheaper and faster with no measurable penalty - a smaller claim than the numbers first suggest, and the only one the data supports.</a:t>
             </a:r>
           </a:p>
         </p:txBody>
@@ -5328,8 +5328,8 @@
         </p:nvSpPr>
         <p:spPr>
           <a:xfrm>
-            <a:off x="822960" y="3108960"/>
-            <a:ext cx="10515600" cy="640080"/>
+            <a:off x="822960" y="3063240"/>
+            <a:ext cx="10515600" cy="457200"/>
           </a:xfrm>
           <a:prstGeom prst="rect">
             <a:avLst/>
@@ -5367,7 +5367,46 @@
         </p:nvSpPr>
         <p:spPr>
           <a:xfrm>
-            <a:off x="822960" y="3931920"/>
+            <a:off x="822960" y="3611880"/>
+            <a:ext cx="10515600" cy="457200"/>
+          </a:xfrm>
+          <a:prstGeom prst="rect">
+            <a:avLst/>
+          </a:prstGeom>
+          <a:noFill/>
+        </p:spPr>
+        <p:txBody>
+          <a:bodyPr wrap="square" anchor="t">
+            <a:spAutoFit/>
+          </a:bodyPr>
+          <a:lstStyle/>
+          <a:p>
+            <a:pPr algn="l">
+              <a:lnSpc>
+                <a:spcPct val="100000"/>
+              </a:lnSpc>
+            </a:pPr>
+            <a:r>
+              <a:rPr sz="1700" b="1">
+                <a:solidFill>
+                  <a:srgbClr val="0EA5A4"/>
+                </a:solidFill>
+                <a:latin typeface="Calibri"/>
+              </a:rPr>
+              <a:t>How it runs:  one AI call, and that is the whole thing.</a:t>
+            </a:r>
+          </a:p>
+        </p:txBody>
+      </p:sp>
+      <p:sp>
+        <p:nvSpPr>
+          <p:cNvPr id="8" name="TextBox 7"/>
+          <p:cNvSpPr txBox="1"/>
+          <p:nvPr/>
+        </p:nvSpPr>
+        <p:spPr>
+          <a:xfrm>
+            <a:off x="822960" y="4206240"/>
             <a:ext cx="3515258" cy="1188720"/>
           </a:xfrm>
           <a:prstGeom prst="rect">
@@ -5400,14 +5439,14 @@
       </p:sp>
       <p:sp>
         <p:nvSpPr>
-          <p:cNvPr id="8" name="TextBox 7"/>
+          <p:cNvPr id="9" name="TextBox 8"/>
           <p:cNvSpPr txBox="1"/>
           <p:nvPr/>
         </p:nvSpPr>
         <p:spPr>
           <a:xfrm>
-            <a:off x="822960" y="5074920"/>
-            <a:ext cx="3515258" cy="731520"/>
+            <a:off x="822960" y="5349240"/>
+            <a:ext cx="3515258" cy="457200"/>
           </a:xfrm>
           <a:prstGeom prst="rect">
             <a:avLst/>
@@ -5439,13 +5478,13 @@
       </p:sp>
       <p:sp>
         <p:nvSpPr>
-          <p:cNvPr id="9" name="TextBox 8"/>
+          <p:cNvPr id="10" name="TextBox 9"/>
           <p:cNvSpPr txBox="1"/>
           <p:nvPr/>
         </p:nvSpPr>
         <p:spPr>
           <a:xfrm>
-            <a:off x="4338218" y="3931920"/>
+            <a:off x="4338218" y="4206240"/>
             <a:ext cx="3515258" cy="1188720"/>
           </a:xfrm>
           <a:prstGeom prst="rect">
@@ -5478,14 +5517,14 @@
       </p:sp>
       <p:sp>
         <p:nvSpPr>
-          <p:cNvPr id="10" name="TextBox 9"/>
+          <p:cNvPr id="11" name="TextBox 10"/>
           <p:cNvSpPr txBox="1"/>
           <p:nvPr/>
         </p:nvSpPr>
         <p:spPr>
           <a:xfrm>
-            <a:off x="4338218" y="5074920"/>
-            <a:ext cx="3515258" cy="731520"/>
+            <a:off x="4338218" y="5349240"/>
+            <a:ext cx="3515258" cy="457200"/>
           </a:xfrm>
           <a:prstGeom prst="rect">
             <a:avLst/>
@@ -5517,13 +5556,13 @@
       </p:sp>
       <p:sp>
         <p:nvSpPr>
-          <p:cNvPr id="11" name="TextBox 10"/>
+          <p:cNvPr id="12" name="TextBox 11"/>
           <p:cNvSpPr txBox="1"/>
           <p:nvPr/>
         </p:nvSpPr>
         <p:spPr>
           <a:xfrm>
-            <a:off x="7853476" y="3931920"/>
+            <a:off x="7853476" y="4206240"/>
             <a:ext cx="3515258" cy="1188720"/>
           </a:xfrm>
           <a:prstGeom prst="rect">
@@ -5556,14 +5595,14 @@
       </p:sp>
       <p:sp>
         <p:nvSpPr>
-          <p:cNvPr id="12" name="TextBox 11"/>
+          <p:cNvPr id="13" name="TextBox 12"/>
           <p:cNvSpPr txBox="1"/>
           <p:nvPr/>
         </p:nvSpPr>
         <p:spPr>
           <a:xfrm>
-            <a:off x="7853476" y="5074920"/>
-            <a:ext cx="3515258" cy="731520"/>
+            <a:off x="7853476" y="5349240"/>
+            <a:ext cx="3515258" cy="457200"/>
           </a:xfrm>
           <a:prstGeom prst="rect">
             <a:avLst/>
@@ -5595,14 +5634,14 @@
       </p:sp>
       <p:sp>
         <p:nvSpPr>
-          <p:cNvPr id="13" name="TextBox 12"/>
+          <p:cNvPr id="14" name="TextBox 13"/>
           <p:cNvSpPr txBox="1"/>
           <p:nvPr/>
         </p:nvSpPr>
         <p:spPr>
           <a:xfrm>
-            <a:off x="822960" y="5669280"/>
-            <a:ext cx="10515600" cy="731520"/>
+            <a:off x="822960" y="5897880"/>
+            <a:ext cx="10515600" cy="457200"/>
           </a:xfrm>
           <a:prstGeom prst="rect">
             <a:avLst/>
@@ -5781,7 +5820,7 @@
           <p:nvPr/>
         </p:nvGraphicFramePr>
         <p:xfrm>
-          <a:off x="822960" y="1965960"/>
+          <a:off x="822960" y="1874519"/>
           <a:ext cx="10515599" cy="2560320"/>
         </p:xfrm>
         <a:graphic>
@@ -6283,8 +6322,8 @@
         </p:nvSpPr>
         <p:spPr>
           <a:xfrm>
-            <a:off x="822960" y="5029200"/>
-            <a:ext cx="10515600" cy="1280160"/>
+            <a:off x="822960" y="4617720"/>
+            <a:ext cx="10515600" cy="1737360"/>
           </a:xfrm>
           <a:prstGeom prst="rect">
             <a:avLst/>
@@ -6299,11 +6338,27 @@
           <a:p>
             <a:pPr algn="l">
               <a:lnSpc>
-                <a:spcPct val="125000"/>
+                <a:spcPct val="120000"/>
               </a:lnSpc>
             </a:pPr>
             <a:r>
-              <a:rPr sz="2000" b="1">
+              <a:rPr sz="1700" b="1">
+                <a:solidFill>
+                  <a:srgbClr val="0EA5A4"/>
+                </a:solidFill>
+                <a:latin typeface="Calibri"/>
+              </a:rPr>
+              <a:t>How they run:  one after another. Flights finish, then hotels, then attractions, then the plan. Nothing overlaps.</a:t>
+            </a:r>
+          </a:p>
+          <a:p>
+            <a:pPr algn="l">
+              <a:lnSpc>
+                <a:spcPct val="120000"/>
+              </a:lnSpc>
+            </a:pPr>
+            <a:r>
+              <a:rPr sz="1900" b="1">
                 <a:solidFill>
                   <a:srgbClr val="161A23"/>
                 </a:solidFill>
@@ -6315,11 +6370,11 @@
           <a:p>
             <a:pPr algn="l">
               <a:lnSpc>
-                <a:spcPct val="125000"/>
+                <a:spcPct val="120000"/>
               </a:lnSpc>
             </a:pPr>
             <a:r>
-              <a:rPr sz="1700" b="1">
+              <a:rPr sz="1600" b="1">
                 <a:solidFill>
                   <a:srgbClr val="A85B00"/>
                 </a:solidFill>
@@ -6479,7 +6534,7 @@
           <p:nvPr/>
         </p:nvGraphicFramePr>
         <p:xfrm>
-          <a:off x="822960" y="2011680"/>
+          <a:off x="822960" y="1920240"/>
           <a:ext cx="10515599" cy="2560320"/>
         </p:xfrm>
         <a:graphic>
@@ -6981,8 +7036,8 @@
         </p:nvSpPr>
         <p:spPr>
           <a:xfrm>
-            <a:off x="822960" y="4572000"/>
-            <a:ext cx="10515600" cy="1737360"/>
+            <a:off x="822960" y="4526280"/>
+            <a:ext cx="10515600" cy="1828800"/>
           </a:xfrm>
           <a:prstGeom prst="rect">
             <a:avLst/>
@@ -6997,65 +7052,65 @@
           <a:p>
             <a:pPr algn="l">
               <a:lnSpc>
-                <a:spcPct val="120000"/>
+                <a:spcPct val="115000"/>
               </a:lnSpc>
             </a:pPr>
             <a:r>
-              <a:rPr sz="1700" b="0">
+              <a:rPr sz="1700" b="1">
                 <a:solidFill>
-                  <a:srgbClr val="161A23"/>
+                  <a:srgbClr val="0EA5A4"/>
                 </a:solidFill>
                 <a:latin typeface="Calibri"/>
               </a:rPr>
-              <a:t>Three changes: fewer tools each, only 3 thinking steps instead of 15, and the AI is shown the best 3 results instead of 12,000 characters.</a:t>
+              <a:t>How they run:  flights, hotels and activities run at the same time, not one after another. Then the coordinator writes the plan.</a:t>
             </a:r>
           </a:p>
           <a:p>
             <a:pPr algn="l">
               <a:lnSpc>
-                <a:spcPct val="120000"/>
+                <a:spcPct val="115000"/>
               </a:lnSpc>
             </a:pPr>
             <a:r>
-              <a:rPr sz="500" b="0">
+              <a:rPr sz="1500" b="0">
                 <a:solidFill>
-                  <a:srgbClr val="161A23"/>
+                  <a:srgbClr val="545C6E"/>
                 </a:solidFill>
                 <a:latin typeface="Calibri"/>
               </a:rPr>
-              <a:t/>
+              <a:t>Also: fewer tools each, 3 thinking steps instead of 15, and the AI is shown the best 3 results instead of 12,000 characters.</a:t>
             </a:r>
           </a:p>
           <a:p>
             <a:pPr algn="l">
               <a:lnSpc>
-                <a:spcPct val="120000"/>
+                <a:spcPct val="115000"/>
               </a:lnSpc>
             </a:pPr>
             <a:r>
-              <a:rPr sz="2000" b="1">
+              <a:rPr sz="1900" b="1">
                 <a:solidFill>
                   <a:srgbClr val="4338CA"/>
                 </a:solidFill>
                 <a:latin typeface="Calibri"/>
               </a:rPr>
-              <a:t>Result: 89% less text sent, and 10 AI calls instead of 21.</a:t>
+              <a:t>Result: 89% less text than B, 10 AI calls instead of 21, and 37s instead of 372s.</a:t>
             </a:r>
           </a:p>
           <a:p>
             <a:pPr algn="l">
               <a:lnSpc>
-                <a:spcPct val="120000"/>
+                <a:spcPct val="115000"/>
               </a:lnSpc>
             </a:pPr>
             <a:r>
-              <a:rPr sz="1700" b="1">
+              <a:rPr sz="1600" b="1">
                 <a:solidFill>
                   <a:srgbClr val="A85B00"/>
                 </a:solidFill>
                 <a:latin typeface="Calibri"/>
               </a:rPr>
-              <a:t>Worth saying out loud: most of B's cost was bad setup, not the design.</a:t>
+              <a:t>So most of B's cost was bad setup, not the design.</a:t>
             </a:r>
           </a:p>
         </p:txBody>
@@ -7209,7 +7264,7 @@
           <p:nvPr/>
         </p:nvGraphicFramePr>
         <p:xfrm>
-          <a:off x="822960" y="2011680"/>
+          <a:off x="822960" y="1965960"/>
           <a:ext cx="10515599" cy="1828800"/>
         </p:xfrm>
         <a:graphic>
@@ -7575,8 +7630,8 @@
         </p:nvSpPr>
         <p:spPr>
           <a:xfrm>
-            <a:off x="822960" y="3886200"/>
-            <a:ext cx="10515600" cy="457200"/>
+            <a:off x="822960" y="4069080"/>
+            <a:ext cx="10515600" cy="1005840"/>
           </a:xfrm>
           <a:prstGeom prst="rect">
             <a:avLst/>
@@ -7591,46 +7646,23 @@
           <a:p>
             <a:pPr algn="l">
               <a:lnSpc>
-                <a:spcPct val="100000"/>
+                <a:spcPct val="115000"/>
               </a:lnSpc>
             </a:pPr>
             <a:r>
-              <a:rPr sz="1800" b="1">
+              <a:rPr sz="1700" b="1">
                 <a:solidFill>
-                  <a:srgbClr val="161A23"/>
+                  <a:srgbClr val="0EA5A4"/>
                 </a:solidFill>
                 <a:latin typeface="Calibri"/>
               </a:rPr>
-              <a:t>The three search agents are gone. Plain Python fetches the flights, hotels, attractions and restaurants.</a:t>
-            </a:r>
-          </a:p>
-        </p:txBody>
-      </p:sp>
-      <p:sp>
-        <p:nvSpPr>
-          <p:cNvPr id="7" name="TextBox 6"/>
-          <p:cNvSpPr txBox="1"/>
-          <p:nvPr/>
-        </p:nvSpPr>
-        <p:spPr>
-          <a:xfrm>
-            <a:off x="822960" y="4389120"/>
-            <a:ext cx="10515600" cy="457200"/>
-          </a:xfrm>
-          <a:prstGeom prst="rect">
-            <a:avLst/>
-          </a:prstGeom>
-          <a:noFill/>
-        </p:spPr>
-        <p:txBody>
-          <a:bodyPr wrap="square" anchor="t">
-            <a:spAutoFit/>
-          </a:bodyPr>
-          <a:lstStyle/>
+              <a:t>How it runs:  three steps. AI reads the request  →  Python fetches the flights, hotels, attractions and restaurants  →  AI writes the plan.</a:t>
+            </a:r>
+          </a:p>
           <a:p>
             <a:pPr algn="l">
               <a:lnSpc>
-                <a:spcPct val="100000"/>
+                <a:spcPct val="115000"/>
               </a:lnSpc>
             </a:pPr>
             <a:r>
@@ -7647,13 +7679,13 @@
       </p:sp>
       <p:sp>
         <p:nvSpPr>
-          <p:cNvPr id="8" name="TextBox 7"/>
+          <p:cNvPr id="7" name="TextBox 6"/>
           <p:cNvSpPr txBox="1"/>
           <p:nvPr/>
         </p:nvSpPr>
         <p:spPr>
           <a:xfrm>
-            <a:off x="822960" y="4892040"/>
+            <a:off x="822960" y="5120640"/>
             <a:ext cx="3515258" cy="1188720"/>
           </a:xfrm>
           <a:prstGeom prst="rect">
@@ -7686,14 +7718,14 @@
       </p:sp>
       <p:sp>
         <p:nvSpPr>
-          <p:cNvPr id="9" name="TextBox 8"/>
+          <p:cNvPr id="8" name="TextBox 7"/>
           <p:cNvSpPr txBox="1"/>
           <p:nvPr/>
         </p:nvSpPr>
         <p:spPr>
           <a:xfrm>
-            <a:off x="822960" y="6035040"/>
-            <a:ext cx="3515258" cy="731520"/>
+            <a:off x="822960" y="6263640"/>
+            <a:ext cx="3515258" cy="457200"/>
           </a:xfrm>
           <a:prstGeom prst="rect">
             <a:avLst/>
@@ -7725,13 +7757,13 @@
       </p:sp>
       <p:sp>
         <p:nvSpPr>
-          <p:cNvPr id="10" name="TextBox 9"/>
+          <p:cNvPr id="9" name="TextBox 8"/>
           <p:cNvSpPr txBox="1"/>
           <p:nvPr/>
         </p:nvSpPr>
         <p:spPr>
           <a:xfrm>
-            <a:off x="4338218" y="4892040"/>
+            <a:off x="4338218" y="5120640"/>
             <a:ext cx="3515258" cy="1188720"/>
           </a:xfrm>
           <a:prstGeom prst="rect">
@@ -7764,14 +7796,14 @@
       </p:sp>
       <p:sp>
         <p:nvSpPr>
-          <p:cNvPr id="11" name="TextBox 10"/>
+          <p:cNvPr id="10" name="TextBox 9"/>
           <p:cNvSpPr txBox="1"/>
           <p:nvPr/>
         </p:nvSpPr>
         <p:spPr>
           <a:xfrm>
-            <a:off x="4338218" y="6035040"/>
-            <a:ext cx="3515258" cy="731520"/>
+            <a:off x="4338218" y="6263640"/>
+            <a:ext cx="3515258" cy="457200"/>
           </a:xfrm>
           <a:prstGeom prst="rect">
             <a:avLst/>
@@ -7803,13 +7835,13 @@
       </p:sp>
       <p:sp>
         <p:nvSpPr>
-          <p:cNvPr id="12" name="TextBox 11"/>
+          <p:cNvPr id="11" name="TextBox 10"/>
           <p:cNvSpPr txBox="1"/>
           <p:nvPr/>
         </p:nvSpPr>
         <p:spPr>
           <a:xfrm>
-            <a:off x="7853476" y="4892040"/>
+            <a:off x="7853476" y="5120640"/>
             <a:ext cx="3515258" cy="1188720"/>
           </a:xfrm>
           <a:prstGeom prst="rect">
@@ -7842,14 +7874,14 @@
       </p:sp>
       <p:sp>
         <p:nvSpPr>
-          <p:cNvPr id="13" name="TextBox 12"/>
+          <p:cNvPr id="12" name="TextBox 11"/>
           <p:cNvSpPr txBox="1"/>
           <p:nvPr/>
         </p:nvSpPr>
         <p:spPr>
           <a:xfrm>
-            <a:off x="7853476" y="6035040"/>
-            <a:ext cx="3515258" cy="731520"/>
+            <a:off x="7853476" y="6263640"/>
+            <a:ext cx="3515258" cy="457200"/>
           </a:xfrm>
           <a:prstGeom prst="rect">
             <a:avLst/>
@@ -7875,45 +7907,6 @@
                 <a:latin typeface="Calibri"/>
               </a:rPr>
               <a:t>searches, every single time</a:t>
-            </a:r>
-          </a:p>
-        </p:txBody>
-      </p:sp>
-      <p:sp>
-        <p:nvSpPr>
-          <p:cNvPr id="14" name="TextBox 13"/>
-          <p:cNvSpPr txBox="1"/>
-          <p:nvPr/>
-        </p:nvSpPr>
-        <p:spPr>
-          <a:xfrm>
-            <a:off x="822960" y="6400800"/>
-            <a:ext cx="10515600" cy="365760"/>
-          </a:xfrm>
-          <a:prstGeom prst="rect">
-            <a:avLst/>
-          </a:prstGeom>
-          <a:noFill/>
-        </p:spPr>
-        <p:txBody>
-          <a:bodyPr wrap="square" anchor="t">
-            <a:spAutoFit/>
-          </a:bodyPr>
-          <a:lstStyle/>
-          <a:p>
-            <a:pPr algn="l">
-              <a:lnSpc>
-                <a:spcPct val="100000"/>
-              </a:lnSpc>
-            </a:pPr>
-            <a:r>
-              <a:rPr sz="1600" b="0">
-                <a:solidFill>
-                  <a:srgbClr val="545C6E"/>
-                </a:solidFill>
-                <a:latin typeface="Calibri"/>
-              </a:rPr>
-              <a:t>Once we know the place and the dates, there is nothing left for AI to decide.</a:t>
             </a:r>
           </a:p>
         </p:txBody>
@@ -8067,8 +8060,8 @@
           <p:nvPr/>
         </p:nvGraphicFramePr>
         <p:xfrm>
-          <a:off x="822960" y="2011680"/>
-          <a:ext cx="10515597" cy="2560320"/>
+          <a:off x="822960" y="1874519"/>
+          <a:ext cx="10515597" cy="2926080"/>
         </p:xfrm>
         <a:graphic>
           <a:graphicData uri="http://schemas.openxmlformats.org/drawingml/2006/table">
@@ -8090,7 +8083,7 @@
                     <a:lstStyle/>
                     <a:p>
                       <a:r>
-                        <a:rPr sz="1400" b="1">
+                        <a:rPr sz="1300" b="1">
                           <a:solidFill>
                             <a:srgbClr val="FFFFFF"/>
                           </a:solidFill>
@@ -8112,7 +8105,7 @@
                     <a:lstStyle/>
                     <a:p>
                       <a:r>
-                        <a:rPr sz="1400" b="1">
+                        <a:rPr sz="1300" b="1">
                           <a:solidFill>
                             <a:srgbClr val="FFFFFF"/>
                           </a:solidFill>
@@ -8134,7 +8127,7 @@
                     <a:lstStyle/>
                     <a:p>
                       <a:r>
-                        <a:rPr sz="1400" b="1">
+                        <a:rPr sz="1300" b="1">
                           <a:solidFill>
                             <a:srgbClr val="FFFFFF"/>
                           </a:solidFill>
@@ -8156,7 +8149,7 @@
                     <a:lstStyle/>
                     <a:p>
                       <a:r>
-                        <a:rPr sz="1400" b="1">
+                        <a:rPr sz="1300" b="1">
                           <a:solidFill>
                             <a:srgbClr val="FFFFFF"/>
                           </a:solidFill>
@@ -8178,7 +8171,7 @@
                     <a:lstStyle/>
                     <a:p>
                       <a:r>
-                        <a:rPr sz="1400" b="1">
+                        <a:rPr sz="1300" b="1">
                           <a:solidFill>
                             <a:srgbClr val="FFFFFF"/>
                           </a:solidFill>
@@ -8202,7 +8195,7 @@
                     <a:lstStyle/>
                     <a:p>
                       <a:r>
-                        <a:rPr sz="1400" b="0">
+                        <a:rPr sz="1300" b="0">
                           <a:solidFill>
                             <a:srgbClr val="161A23"/>
                           </a:solidFill>
@@ -8224,7 +8217,7 @@
                     <a:lstStyle/>
                     <a:p>
                       <a:r>
-                        <a:rPr sz="1400" b="0">
+                        <a:rPr sz="1300" b="0">
                           <a:solidFill>
                             <a:srgbClr val="161A23"/>
                           </a:solidFill>
@@ -8246,7 +8239,7 @@
                     <a:lstStyle/>
                     <a:p>
                       <a:r>
-                        <a:rPr sz="1400" b="0">
+                        <a:rPr sz="1300" b="0">
                           <a:solidFill>
                             <a:srgbClr val="161A23"/>
                           </a:solidFill>
@@ -8268,7 +8261,7 @@
                     <a:lstStyle/>
                     <a:p>
                       <a:r>
-                        <a:rPr sz="1400" b="0">
+                        <a:rPr sz="1300" b="0">
                           <a:solidFill>
                             <a:srgbClr val="161A23"/>
                           </a:solidFill>
@@ -8290,7 +8283,7 @@
                     <a:lstStyle/>
                     <a:p>
                       <a:r>
-                        <a:rPr sz="1400" b="0">
+                        <a:rPr sz="1300" b="0">
                           <a:solidFill>
                             <a:srgbClr val="161A23"/>
                           </a:solidFill>
@@ -8314,13 +8307,13 @@
                     <a:lstStyle/>
                     <a:p>
                       <a:r>
-                        <a:rPr sz="1400" b="0">
+                        <a:rPr sz="1300" b="0">
                           <a:solidFill>
                             <a:srgbClr val="161A23"/>
                           </a:solidFill>
                           <a:latin typeface="Calibri"/>
                         </a:rPr>
-                        <a:t>AI calls</a:t>
+                        <a:t>How the agents run</a:t>
                       </a:r>
                     </a:p>
                   </a:txBody>
@@ -8336,13 +8329,13 @@
                     <a:lstStyle/>
                     <a:p>
                       <a:r>
-                        <a:rPr sz="1400" b="0">
+                        <a:rPr sz="1300" b="0">
                           <a:solidFill>
                             <a:srgbClr val="161A23"/>
                           </a:solidFill>
                           <a:latin typeface="Calibri"/>
                         </a:rPr>
-                        <a:t>1</a:t>
+                        <a:t>one call</a:t>
                       </a:r>
                     </a:p>
                   </a:txBody>
@@ -8358,13 +8351,18 @@
                     <a:lstStyle/>
                     <a:p>
                       <a:r>
-                        <a:rPr sz="1400" b="0">
+                        <a:rPr sz="1300" b="0">
                           <a:solidFill>
                             <a:srgbClr val="161A23"/>
                           </a:solidFill>
                           <a:latin typeface="Calibri"/>
                         </a:rPr>
-                        <a:t>21</a:t>
+                        <a:t>one after</a:t>
+                      </a:r>
+                    </a:p>
+                    <a:p>
+                      <a:r>
+                        <a:t>another</a:t>
                       </a:r>
                     </a:p>
                   </a:txBody>
@@ -8380,13 +8378,18 @@
                     <a:lstStyle/>
                     <a:p>
                       <a:r>
-                        <a:rPr sz="1400" b="0">
+                        <a:rPr sz="1300" b="0">
                           <a:solidFill>
                             <a:srgbClr val="161A23"/>
                           </a:solidFill>
                           <a:latin typeface="Calibri"/>
                         </a:rPr>
-                        <a:t>10</a:t>
+                        <a:t>3 at the</a:t>
+                      </a:r>
+                    </a:p>
+                    <a:p>
+                      <a:r>
+                        <a:t>same time</a:t>
                       </a:r>
                     </a:p>
                   </a:txBody>
@@ -8402,13 +8405,18 @@
                     <a:lstStyle/>
                     <a:p>
                       <a:r>
-                        <a:rPr sz="1400" b="0">
+                        <a:rPr sz="1300" b="0">
                           <a:solidFill>
                             <a:srgbClr val="161A23"/>
                           </a:solidFill>
                           <a:latin typeface="Calibri"/>
                         </a:rPr>
-                        <a:t>2</a:t>
+                        <a:t>AI → Python</a:t>
+                      </a:r>
+                    </a:p>
+                    <a:p>
+                      <a:r>
+                        <a:t>→ AI</a:t>
                       </a:r>
                     </a:p>
                   </a:txBody>
@@ -8426,13 +8434,13 @@
                     <a:lstStyle/>
                     <a:p>
                       <a:r>
-                        <a:rPr sz="1400" b="0">
+                        <a:rPr sz="1300" b="0">
                           <a:solidFill>
                             <a:srgbClr val="161A23"/>
                           </a:solidFill>
                           <a:latin typeface="Calibri"/>
                         </a:rPr>
-                        <a:t>Text sent to the AI</a:t>
+                        <a:t>AI calls</a:t>
                       </a:r>
                     </a:p>
                   </a:txBody>
@@ -8448,13 +8456,13 @@
                     <a:lstStyle/>
                     <a:p>
                       <a:r>
-                        <a:rPr sz="1400" b="0">
+                        <a:rPr sz="1300" b="0">
                           <a:solidFill>
                             <a:srgbClr val="161A23"/>
                           </a:solidFill>
                           <a:latin typeface="Calibri"/>
                         </a:rPr>
-                        <a:t>4,644</a:t>
+                        <a:t>1</a:t>
                       </a:r>
                     </a:p>
                   </a:txBody>
@@ -8470,13 +8478,13 @@
                     <a:lstStyle/>
                     <a:p>
                       <a:r>
-                        <a:rPr sz="1400" b="0">
+                        <a:rPr sz="1300" b="0">
                           <a:solidFill>
                             <a:srgbClr val="161A23"/>
                           </a:solidFill>
                           <a:latin typeface="Calibri"/>
                         </a:rPr>
-                        <a:t>120,703</a:t>
+                        <a:t>21</a:t>
                       </a:r>
                     </a:p>
                   </a:txBody>
@@ -8492,13 +8500,13 @@
                     <a:lstStyle/>
                     <a:p>
                       <a:r>
-                        <a:rPr sz="1400" b="0">
+                        <a:rPr sz="1300" b="0">
                           <a:solidFill>
                             <a:srgbClr val="161A23"/>
                           </a:solidFill>
                           <a:latin typeface="Calibri"/>
                         </a:rPr>
-                        <a:t>13,521</a:t>
+                        <a:t>10</a:t>
                       </a:r>
                     </a:p>
                   </a:txBody>
@@ -8514,13 +8522,13 @@
                     <a:lstStyle/>
                     <a:p>
                       <a:r>
-                        <a:rPr sz="1400" b="0">
+                        <a:rPr sz="1300" b="0">
                           <a:solidFill>
                             <a:srgbClr val="161A23"/>
                           </a:solidFill>
                           <a:latin typeface="Calibri"/>
                         </a:rPr>
-                        <a:t>7,840</a:t>
+                        <a:t>2</a:t>
                       </a:r>
                     </a:p>
                   </a:txBody>
@@ -8538,13 +8546,13 @@
                     <a:lstStyle/>
                     <a:p>
                       <a:r>
-                        <a:rPr sz="1400" b="0">
+                        <a:rPr sz="1300" b="0">
                           <a:solidFill>
                             <a:srgbClr val="161A23"/>
                           </a:solidFill>
                           <a:latin typeface="Calibri"/>
                         </a:rPr>
-                        <a:t>Cost per trip</a:t>
+                        <a:t>Text sent to the AI</a:t>
                       </a:r>
                     </a:p>
                   </a:txBody>
@@ -8560,13 +8568,13 @@
                     <a:lstStyle/>
                     <a:p>
                       <a:r>
-                        <a:rPr sz="1400" b="0">
+                        <a:rPr sz="1300" b="0">
                           <a:solidFill>
                             <a:srgbClr val="161A23"/>
                           </a:solidFill>
                           <a:latin typeface="Calibri"/>
                         </a:rPr>
-                        <a:t>$0.0170</a:t>
+                        <a:t>4,644</a:t>
                       </a:r>
                     </a:p>
                   </a:txBody>
@@ -8582,13 +8590,13 @@
                     <a:lstStyle/>
                     <a:p>
                       <a:r>
-                        <a:rPr sz="1400" b="0">
+                        <a:rPr sz="1300" b="0">
                           <a:solidFill>
                             <a:srgbClr val="161A23"/>
                           </a:solidFill>
                           <a:latin typeface="Calibri"/>
                         </a:rPr>
-                        <a:t>$0.1859</a:t>
+                        <a:t>120,703</a:t>
                       </a:r>
                     </a:p>
                   </a:txBody>
@@ -8604,13 +8612,13 @@
                     <a:lstStyle/>
                     <a:p>
                       <a:r>
-                        <a:rPr sz="1400" b="0">
+                        <a:rPr sz="1300" b="0">
                           <a:solidFill>
                             <a:srgbClr val="161A23"/>
                           </a:solidFill>
                           <a:latin typeface="Calibri"/>
                         </a:rPr>
-                        <a:t>$0.0313</a:t>
+                        <a:t>13,521</a:t>
                       </a:r>
                     </a:p>
                   </a:txBody>
@@ -8626,13 +8634,13 @@
                     <a:lstStyle/>
                     <a:p>
                       <a:r>
-                        <a:rPr sz="1400" b="0">
+                        <a:rPr sz="1300" b="0">
                           <a:solidFill>
                             <a:srgbClr val="161A23"/>
                           </a:solidFill>
                           <a:latin typeface="Calibri"/>
                         </a:rPr>
-                        <a:t>$0.0179</a:t>
+                        <a:t>7,840</a:t>
                       </a:r>
                     </a:p>
                   </a:txBody>
@@ -8650,13 +8658,13 @@
                     <a:lstStyle/>
                     <a:p>
                       <a:r>
-                        <a:rPr sz="1400" b="0">
+                        <a:rPr sz="1300" b="0">
                           <a:solidFill>
                             <a:srgbClr val="161A23"/>
                           </a:solidFill>
                           <a:latin typeface="Calibri"/>
                         </a:rPr>
-                        <a:t>Time</a:t>
+                        <a:t>Cost per trip</a:t>
                       </a:r>
                     </a:p>
                   </a:txBody>
@@ -8672,13 +8680,13 @@
                     <a:lstStyle/>
                     <a:p>
                       <a:r>
-                        <a:rPr sz="1400" b="0">
+                        <a:rPr sz="1300" b="0">
                           <a:solidFill>
                             <a:srgbClr val="161A23"/>
                           </a:solidFill>
                           <a:latin typeface="Calibri"/>
                         </a:rPr>
-                        <a:t>27s</a:t>
+                        <a:t>$0.0170</a:t>
                       </a:r>
                     </a:p>
                   </a:txBody>
@@ -8694,13 +8702,13 @@
                     <a:lstStyle/>
                     <a:p>
                       <a:r>
-                        <a:rPr sz="1400" b="0">
+                        <a:rPr sz="1300" b="0">
                           <a:solidFill>
                             <a:srgbClr val="161A23"/>
                           </a:solidFill>
                           <a:latin typeface="Calibri"/>
                         </a:rPr>
-                        <a:t>372s</a:t>
+                        <a:t>$0.1859</a:t>
                       </a:r>
                     </a:p>
                   </a:txBody>
@@ -8716,13 +8724,13 @@
                     <a:lstStyle/>
                     <a:p>
                       <a:r>
-                        <a:rPr sz="1400" b="0">
+                        <a:rPr sz="1300" b="0">
                           <a:solidFill>
                             <a:srgbClr val="161A23"/>
                           </a:solidFill>
                           <a:latin typeface="Calibri"/>
                         </a:rPr>
-                        <a:t>37s</a:t>
+                        <a:t>$0.0313</a:t>
                       </a:r>
                     </a:p>
                   </a:txBody>
@@ -8738,13 +8746,13 @@
                     <a:lstStyle/>
                     <a:p>
                       <a:r>
-                        <a:rPr sz="1400" b="0">
+                        <a:rPr sz="1300" b="0">
                           <a:solidFill>
                             <a:srgbClr val="161A23"/>
                           </a:solidFill>
                           <a:latin typeface="Calibri"/>
                         </a:rPr>
-                        <a:t>23s</a:t>
+                        <a:t>$0.0179</a:t>
                       </a:r>
                     </a:p>
                   </a:txBody>
@@ -8762,29 +8770,141 @@
                     <a:lstStyle/>
                     <a:p>
                       <a:r>
-                        <a:rPr sz="1400" b="0">
+                        <a:rPr sz="1300" b="0">
                           <a:solidFill>
                             <a:srgbClr val="161A23"/>
                           </a:solidFill>
                           <a:latin typeface="Calibri"/>
                         </a:rPr>
+                        <a:t>Time</a:t>
+                      </a:r>
+                    </a:p>
+                  </a:txBody>
+                  <a:tcPr>
+                    <a:solidFill>
+                      <a:srgbClr val="F7F8FC"/>
+                    </a:solidFill>
+                  </a:tcPr>
+                </a:tc>
+                <a:tc>
+                  <a:txBody>
+                    <a:bodyPr/>
+                    <a:lstStyle/>
+                    <a:p>
+                      <a:r>
+                        <a:rPr sz="1300" b="0">
+                          <a:solidFill>
+                            <a:srgbClr val="161A23"/>
+                          </a:solidFill>
+                          <a:latin typeface="Calibri"/>
+                        </a:rPr>
+                        <a:t>27s</a:t>
+                      </a:r>
+                    </a:p>
+                  </a:txBody>
+                  <a:tcPr>
+                    <a:solidFill>
+                      <a:srgbClr val="F7F8FC"/>
+                    </a:solidFill>
+                  </a:tcPr>
+                </a:tc>
+                <a:tc>
+                  <a:txBody>
+                    <a:bodyPr/>
+                    <a:lstStyle/>
+                    <a:p>
+                      <a:r>
+                        <a:rPr sz="1300" b="0">
+                          <a:solidFill>
+                            <a:srgbClr val="161A23"/>
+                          </a:solidFill>
+                          <a:latin typeface="Calibri"/>
+                        </a:rPr>
+                        <a:t>372s</a:t>
+                      </a:r>
+                    </a:p>
+                  </a:txBody>
+                  <a:tcPr>
+                    <a:solidFill>
+                      <a:srgbClr val="F7F8FC"/>
+                    </a:solidFill>
+                  </a:tcPr>
+                </a:tc>
+                <a:tc>
+                  <a:txBody>
+                    <a:bodyPr/>
+                    <a:lstStyle/>
+                    <a:p>
+                      <a:r>
+                        <a:rPr sz="1300" b="0">
+                          <a:solidFill>
+                            <a:srgbClr val="161A23"/>
+                          </a:solidFill>
+                          <a:latin typeface="Calibri"/>
+                        </a:rPr>
+                        <a:t>37s</a:t>
+                      </a:r>
+                    </a:p>
+                  </a:txBody>
+                  <a:tcPr>
+                    <a:solidFill>
+                      <a:srgbClr val="F7F8FC"/>
+                    </a:solidFill>
+                  </a:tcPr>
+                </a:tc>
+                <a:tc>
+                  <a:txBody>
+                    <a:bodyPr/>
+                    <a:lstStyle/>
+                    <a:p>
+                      <a:r>
+                        <a:rPr sz="1300" b="0">
+                          <a:solidFill>
+                            <a:srgbClr val="161A23"/>
+                          </a:solidFill>
+                          <a:latin typeface="Calibri"/>
+                        </a:rPr>
+                        <a:t>23s</a:t>
+                      </a:r>
+                    </a:p>
+                  </a:txBody>
+                  <a:tcPr>
+                    <a:solidFill>
+                      <a:srgbClr val="F7F8FC"/>
+                    </a:solidFill>
+                  </a:tcPr>
+                </a:tc>
+              </a:tr>
+              <a:tr h="365760">
+                <a:tc>
+                  <a:txBody>
+                    <a:bodyPr/>
+                    <a:lstStyle/>
+                    <a:p>
+                      <a:r>
+                        <a:rPr sz="1300" b="0">
+                          <a:solidFill>
+                            <a:srgbClr val="161A23"/>
+                          </a:solidFill>
+                          <a:latin typeface="Calibri"/>
+                        </a:rPr>
                         <a:t>Prices that were real</a:t>
                       </a:r>
                     </a:p>
                   </a:txBody>
                   <a:tcPr>
                     <a:solidFill>
-                      <a:srgbClr val="F7F8FC"/>
-                    </a:solidFill>
-                  </a:tcPr>
-                </a:tc>
-                <a:tc>
-                  <a:txBody>
-                    <a:bodyPr/>
-                    <a:lstStyle/>
-                    <a:p>
-                      <a:r>
-                        <a:rPr sz="1400" b="0">
+                      <a:srgbClr val="FFFFFF"/>
+                    </a:solidFill>
+                  </a:tcPr>
+                </a:tc>
+                <a:tc>
+                  <a:txBody>
+                    <a:bodyPr/>
+                    <a:lstStyle/>
+                    <a:p>
+                      <a:r>
+                        <a:rPr sz="1300" b="0">
                           <a:solidFill>
                             <a:srgbClr val="161A23"/>
                           </a:solidFill>
@@ -8796,17 +8916,17 @@
                   </a:txBody>
                   <a:tcPr>
                     <a:solidFill>
-                      <a:srgbClr val="F7F8FC"/>
-                    </a:solidFill>
-                  </a:tcPr>
-                </a:tc>
-                <a:tc>
-                  <a:txBody>
-                    <a:bodyPr/>
-                    <a:lstStyle/>
-                    <a:p>
-                      <a:r>
-                        <a:rPr sz="1400" b="0">
+                      <a:srgbClr val="FFFFFF"/>
+                    </a:solidFill>
+                  </a:tcPr>
+                </a:tc>
+                <a:tc>
+                  <a:txBody>
+                    <a:bodyPr/>
+                    <a:lstStyle/>
+                    <a:p>
+                      <a:r>
+                        <a:rPr sz="1300" b="0">
                           <a:solidFill>
                             <a:srgbClr val="161A23"/>
                           </a:solidFill>
@@ -8818,17 +8938,17 @@
                   </a:txBody>
                   <a:tcPr>
                     <a:solidFill>
-                      <a:srgbClr val="F7F8FC"/>
-                    </a:solidFill>
-                  </a:tcPr>
-                </a:tc>
-                <a:tc>
-                  <a:txBody>
-                    <a:bodyPr/>
-                    <a:lstStyle/>
-                    <a:p>
-                      <a:r>
-                        <a:rPr sz="1400" b="0">
+                      <a:srgbClr val="FFFFFF"/>
+                    </a:solidFill>
+                  </a:tcPr>
+                </a:tc>
+                <a:tc>
+                  <a:txBody>
+                    <a:bodyPr/>
+                    <a:lstStyle/>
+                    <a:p>
+                      <a:r>
+                        <a:rPr sz="1300" b="0">
                           <a:solidFill>
                             <a:srgbClr val="161A23"/>
                           </a:solidFill>
@@ -8840,17 +8960,17 @@
                   </a:txBody>
                   <a:tcPr>
                     <a:solidFill>
-                      <a:srgbClr val="F7F8FC"/>
-                    </a:solidFill>
-                  </a:tcPr>
-                </a:tc>
-                <a:tc>
-                  <a:txBody>
-                    <a:bodyPr/>
-                    <a:lstStyle/>
-                    <a:p>
-                      <a:r>
-                        <a:rPr sz="1400" b="0">
+                      <a:srgbClr val="FFFFFF"/>
+                    </a:solidFill>
+                  </a:tcPr>
+                </a:tc>
+                <a:tc>
+                  <a:txBody>
+                    <a:bodyPr/>
+                    <a:lstStyle/>
+                    <a:p>
+                      <a:r>
+                        <a:rPr sz="1300" b="0">
                           <a:solidFill>
                             <a:srgbClr val="161A23"/>
                           </a:solidFill>
@@ -8862,7 +8982,7 @@
                   </a:txBody>
                   <a:tcPr>
                     <a:solidFill>
-                      <a:srgbClr val="F7F8FC"/>
+                      <a:srgbClr val="FFFFFF"/>
                     </a:solidFill>
                   </a:tcPr>
                 </a:tc>
@@ -9138,7 +9258,7 @@
         <p:spPr>
           <a:xfrm>
             <a:off x="822960" y="6126480"/>
-            <a:ext cx="3515258" cy="731520"/>
+            <a:ext cx="3515258" cy="457200"/>
           </a:xfrm>
           <a:prstGeom prst="rect">
             <a:avLst/>
@@ -9216,7 +9336,7 @@
         <p:spPr>
           <a:xfrm>
             <a:off x="4338218" y="6126480"/>
-            <a:ext cx="3515258" cy="731520"/>
+            <a:ext cx="3515258" cy="457200"/>
           </a:xfrm>
           <a:prstGeom prst="rect">
             <a:avLst/>
@@ -9294,7 +9414,7 @@
         <p:spPr>
           <a:xfrm>
             <a:off x="7853476" y="6126480"/>
-            <a:ext cx="3515258" cy="731520"/>
+            <a:ext cx="3515258" cy="457200"/>
           </a:xfrm>
           <a:prstGeom prst="rect">
             <a:avLst/>

</xml_diff>

<commit_message>
Plainer wording on the viva slides
Sixteen explaining lines rewritten in commoner words and shorter sentences.
"one at a time" for "one after another. Nothing overlaps", "The two overlap"
for "their ranges overlap", "the free APIs ran out" for "because of the free
API limits". Nothing structural changed: the same nine slides, the same
tables, the same tool names and the same measured numbers.

These lines are read aloud from the front of a room, which is the test they
were failing.
</commit_message>
<xml_diff>
--- a/submission/CMP7200_Viva_Presentation.pptx
+++ b/submission/CMP7200_Viva_Presentation.pptx
@@ -5012,7 +5012,7 @@
                 </a:solidFill>
                 <a:latin typeface="Calibri"/>
               </a:rPr>
-              <a:t>Six agents. The next four slides show which of them each approach uses, and what tools each one is given.</a:t>
+              <a:t>Six agents. The next four slides show which ones each approach uses, and what tools they get.</a:t>
             </a:r>
           </a:p>
         </p:txBody>
@@ -5666,7 +5666,7 @@
                 </a:solidFill>
                 <a:latin typeface="Calibri"/>
               </a:rPr>
-              <a:t>So it makes the prices up. This is the baseline everything else has to beat.</a:t>
+              <a:t>So it makes the prices up. Every other approach has to beat this.</a:t>
             </a:r>
           </a:p>
         </p:txBody>
@@ -6348,7 +6348,7 @@
                 </a:solidFill>
                 <a:latin typeface="Calibri"/>
               </a:rPr>
-              <a:t>How they run:  one after another. Flights finish, then hotels, then attractions, then the plan. Nothing overlaps.</a:t>
+              <a:t>How they run:  one at a time. Flights, then hotels, then attractions, then the plan.</a:t>
             </a:r>
           </a:p>
           <a:p>
@@ -6380,7 +6380,7 @@
                 </a:solidFill>
                 <a:latin typeface="Calibri"/>
               </a:rPr>
-              <a:t>Too much freedom: the agents keep thinking and searching — and they still never called two of their own tools.</a:t>
+              <a:t>Too much freedom. They keep thinking and searching, and they still never used two of their own tools.</a:t>
             </a:r>
           </a:p>
         </p:txBody>
@@ -7062,7 +7062,7 @@
                 </a:solidFill>
                 <a:latin typeface="Calibri"/>
               </a:rPr>
-              <a:t>How they run:  flights, hotels and activities run at the same time, not one after another. Then the coordinator writes the plan.</a:t>
+              <a:t>How they run:  flights, hotels and activities all at the same time. Then one agent writes the plan.</a:t>
             </a:r>
           </a:p>
           <a:p>
@@ -7078,7 +7078,7 @@
                 </a:solidFill>
                 <a:latin typeface="Calibri"/>
               </a:rPr>
-              <a:t>Also: fewer tools each, 3 thinking steps instead of 15, and the AI is shown the best 3 results instead of 12,000 characters.</a:t>
+              <a:t>We also gave each agent fewer tools, 3 thinking steps instead of 15, and the best 3 results instead of 12,000 characters of data.</a:t>
             </a:r>
           </a:p>
           <a:p>
@@ -7110,7 +7110,7 @@
                 </a:solidFill>
                 <a:latin typeface="Calibri"/>
               </a:rPr>
-              <a:t>So most of B's cost was bad setup, not the design.</a:t>
+              <a:t>So most of B's cost was bad setup, not a bad design.</a:t>
             </a:r>
           </a:p>
         </p:txBody>
@@ -7656,7 +7656,7 @@
                 </a:solidFill>
                 <a:latin typeface="Calibri"/>
               </a:rPr>
-              <a:t>How it runs:  three steps. AI reads the request  →  Python fetches the flights, hotels, attractions and restaurants  →  AI writes the plan.</a:t>
+              <a:t>How it runs:  three steps. AI reads the request. Python fetches the flights, hotels, attractions and restaurants. AI writes the plan.</a:t>
             </a:r>
           </a:p>
           <a:p>
@@ -7672,7 +7672,7 @@
                 </a:solidFill>
                 <a:latin typeface="Calibri"/>
               </a:rPr>
-              <a:t>(In the web app the coordinator keeps 4 helper tools — calculate, search_internet, search_attractions, search_restaurants. The measured run removes them.)</a:t>
+              <a:t>(The web app leaves 4 helper tools on the last agent. The measured run takes them away, so the comparison is clean.)</a:t>
             </a:r>
           </a:p>
         </p:txBody>
@@ -9025,7 +9025,7 @@
                 </a:solidFill>
                 <a:latin typeface="Calibri"/>
               </a:rPr>
-              <a:t>Being honest: D is not more accurate than C — their ranges overlap.</a:t>
+              <a:t>Being honest: D is not more accurate than C. The two overlap.</a:t>
             </a:r>
           </a:p>
           <a:p>
@@ -9041,7 +9041,7 @@
                 </a:solidFill>
                 <a:latin typeface="Calibri"/>
               </a:rPr>
-              <a:t>What D is: 1.7x cheaper than C and 15x cheaper than B, with no drop in accuracy.</a:t>
+              <a:t>What D is: 1.7x cheaper than C, 15x cheaper than B, and just as accurate.</a:t>
             </a:r>
           </a:p>
         </p:txBody>
@@ -9137,7 +9137,7 @@
                 </a:solidFill>
                 <a:latin typeface="Calibri"/>
               </a:rPr>
-              <a:t>And the check that stops an impossible trip</a:t>
+              <a:t>And the check that stops a trip nobody could afford</a:t>
             </a:r>
           </a:p>
         </p:txBody>
@@ -9674,7 +9674,7 @@
                 </a:solidFill>
                 <a:latin typeface="Calibri"/>
               </a:rPr>
-              <a:t>1.  Without tools, AI makes travel prices up. Tools are essential.</a:t>
+              <a:t>1.  With no tools, AI makes prices up. Tools are essential.</a:t>
             </a:r>
           </a:p>
           <a:p>
@@ -9690,7 +9690,7 @@
                 </a:solidFill>
                 <a:latin typeface="Calibri"/>
               </a:rPr>
-              <a:t>2.  Setup matters hugely — settings alone saved 89% of the cost.</a:t>
+              <a:t>2.  Setup matters. Settings alone saved 89% of the cost.</a:t>
             </a:r>
           </a:p>
           <a:p>
@@ -9706,7 +9706,7 @@
                 </a:solidFill>
                 <a:latin typeface="Calibri"/>
               </a:rPr>
-              <a:t>3.  Taking AI out of the searching is cheaper and faster, and just as accurate.</a:t>
+              <a:t>3.  Taking AI out of the searching is cheaper, faster and just as accurate.</a:t>
             </a:r>
           </a:p>
           <a:p>
@@ -9738,7 +9738,7 @@
                 </a:solidFill>
                 <a:latin typeface="Calibri"/>
               </a:rPr>
-              <a:t>Honest gap: only 1 of 20 trips measured for cost, because of the free API limits.</a:t>
+              <a:t>Honest gap: cost was measured on only 1 of 20 trips, because the free APIs ran out.</a:t>
             </a:r>
           </a:p>
         </p:txBody>

</xml_diff>